<commit_message>
Cierre QAQC al corte 31-08-2026 — los tres proyectos
El punch de Desaladora trae un tercer estado, ATRASADO, además de ABIERTO y
CERRADO: son abiertos que el propio proyecto marca fuera de plazo. Se
respetan como atrasados sin mirar la fecha. Los 10 del corte ya la tenían
vencida, así que la cifra no cambia —pero uno marcado ATRASADO con fecha
futura habría contado como en plazo, contradiciendo al archivo.

Desaladora corte 25-08: punch 1.722 (+126), 1.169 cerrados (+77), P1 68,8%.
El % baja porque entraron 126 punch nuevos y 49 abiertos. Talabre al 31-08:
2.078 DT, P1 93,2%, atrasados 125 (-23), los tres cruces cuadran. Arqueros
corte 24-08: P1 58,1%, cierra dos.

98 comprobaciones OK · suite verificada en 1366/1920/2560.

Co-Authored-By: Claude Opus 5 <noreply@anthropic.com>
Claude-Session: https://claude.ai/code/session_011SHyPcub1TtjA2kTAsaPFu
</commit_message>
<xml_diff>
--- a/panel_control_TOP_P1/Panel_Control_TOP_P1.pptx
+++ b/panel_control_TOP_P1/Panel_Control_TOP_P1.pptx
@@ -233,10 +233,10 @@
                 <c:formatCode>General</c:formatCode>
                 <c:ptCount val="2"/>
                 <c:pt idx="0">
-                  <c:v>46</c:v>
+                  <c:v>49</c:v>
                 </c:pt>
                 <c:pt idx="1">
-                  <c:v>11</c:v>
+                  <c:v>12</c:v>
                 </c:pt>
               </c:numCache>
             </c:numRef>
@@ -311,10 +311,10 @@
                 <c:formatCode>General</c:formatCode>
                 <c:ptCount val="2"/>
                 <c:pt idx="0">
-                  <c:v>34</c:v>
+                  <c:v>31</c:v>
                 </c:pt>
                 <c:pt idx="1">
-                  <c:v>4</c:v>
+                  <c:v>3</c:v>
                 </c:pt>
               </c:numCache>
             </c:numRef>
@@ -687,13 +687,13 @@
               <c:numCache>
                 <c:ptCount val="3"/>
                 <c:pt idx="0">
-                  <c:v>1154</c:v>
+                  <c:v>1156</c:v>
                 </c:pt>
                 <c:pt idx="1">
-                  <c:v>826</c:v>
+                  <c:v>825</c:v>
                 </c:pt>
                 <c:pt idx="2">
-                  <c:v>8</c:v>
+                  <c:v>7</c:v>
                 </c:pt>
               </c:numCache>
             </c:numRef>
@@ -817,9 +817,9 @@
           </c:dLbls>
           <c:cat>
             <c:multiLvlStrRef>
-              <c:f>Sheet1!$A$2:$A$6</c:f>
+              <c:f>Sheet1!$A$2:$A$7</c:f>
               <c:multiLvlStrCache>
-                <c:ptCount val="5"/>
+                <c:ptCount val="6"/>
                 <c:lvl>
                   <c:pt idx="0">
                     <c:v>Eléctrica</c:v>
@@ -834,6 +834,9 @@
                     <c:v>Mecánica</c:v>
                   </c:pt>
                   <c:pt idx="4">
+                    <c:v>Instr. y Control</c:v>
+                  </c:pt>
+                  <c:pt idx="5">
                     <c:v>Estructura</c:v>
                   </c:pt>
                 </c:lvl>
@@ -842,15 +845,15 @@
           </c:cat>
           <c:val>
             <c:numRef>
-              <c:f>Sheet1!$B$2:$B$6</c:f>
+              <c:f>Sheet1!$B$2:$B$7</c:f>
               <c:numCache>
                 <c:formatCode>General</c:formatCode>
-                <c:ptCount val="5"/>
+                <c:ptCount val="6"/>
                 <c:pt idx="0">
-                  <c:v>3</c:v>
+                  <c:v>6</c:v>
                 </c:pt>
                 <c:pt idx="1">
-                  <c:v>5</c:v>
+                  <c:v>2</c:v>
                 </c:pt>
                 <c:pt idx="2">
                   <c:v/>
@@ -859,6 +862,9 @@
                   <c:v/>
                 </c:pt>
                 <c:pt idx="4">
+                  <c:v/>
+                </c:pt>
+                <c:pt idx="5">
                   <c:v/>
                 </c:pt>
               </c:numCache>
@@ -913,9 +919,9 @@
           </c:dLbls>
           <c:cat>
             <c:multiLvlStrRef>
-              <c:f>Sheet1!$A$2:$A$6</c:f>
+              <c:f>Sheet1!$A$2:$A$7</c:f>
               <c:multiLvlStrCache>
-                <c:ptCount val="5"/>
+                <c:ptCount val="6"/>
                 <c:lvl>
                   <c:pt idx="0">
                     <c:v>Eléctrica</c:v>
@@ -930,6 +936,9 @@
                     <c:v>Mecánica</c:v>
                   </c:pt>
                   <c:pt idx="4">
+                    <c:v>Instr. y Control</c:v>
+                  </c:pt>
+                  <c:pt idx="5">
                     <c:v>Estructura</c:v>
                   </c:pt>
                 </c:lvl>
@@ -938,23 +947,26 @@
           </c:cat>
           <c:val>
             <c:numRef>
-              <c:f>Sheet1!$C$2:$C$6</c:f>
+              <c:f>Sheet1!$C$2:$C$7</c:f>
               <c:numCache>
                 <c:formatCode>General</c:formatCode>
-                <c:ptCount val="5"/>
+                <c:ptCount val="6"/>
                 <c:pt idx="0">
-                  <c:v>161</c:v>
+                  <c:v>160</c:v>
                 </c:pt>
                 <c:pt idx="1">
-                  <c:v>60</c:v>
+                  <c:v>91</c:v>
                 </c:pt>
                 <c:pt idx="2">
                   <c:v>20</c:v>
                 </c:pt>
                 <c:pt idx="3">
-                  <c:v>19</c:v>
+                  <c:v>18</c:v>
                 </c:pt>
                 <c:pt idx="4">
+                  <c:v>15</c:v>
+                </c:pt>
+                <c:pt idx="5">
                   <c:v>12</c:v>
                 </c:pt>
               </c:numCache>
@@ -1328,13 +1340,13 @@
               <c:numCache>
                 <c:ptCount val="3"/>
                 <c:pt idx="0">
-                  <c:v>676</c:v>
+                  <c:v>714</c:v>
                 </c:pt>
                 <c:pt idx="1">
                   <c:v>8</c:v>
                 </c:pt>
                 <c:pt idx="2">
-                  <c:v>272</c:v>
+                  <c:v>316</c:v>
                 </c:pt>
               </c:numCache>
             </c:numRef>
@@ -1515,7 +1527,7 @@
                   <c:v>14</c:v>
                 </c:pt>
                 <c:pt idx="5">
-                  <c:v>6</c:v>
+                  <c:v>10</c:v>
                 </c:pt>
                 <c:pt idx="6">
                   <c:v>110</c:v>
@@ -1620,13 +1632,13 @@
                 <c:formatCode>General</c:formatCode>
                 <c:ptCount val="9"/>
                 <c:pt idx="0">
-                  <c:v>3</c:v>
+                  <c:v/>
                 </c:pt>
                 <c:pt idx="1">
                   <c:v/>
                 </c:pt>
                 <c:pt idx="2">
-                  <c:v/>
+                  <c:v>1</c:v>
                 </c:pt>
                 <c:pt idx="3">
                   <c:v/>
@@ -1635,7 +1647,7 @@
                   <c:v/>
                 </c:pt>
                 <c:pt idx="5">
-                  <c:v>16</c:v>
+                  <c:v>6</c:v>
                 </c:pt>
                 <c:pt idx="6">
                   <c:v/>
@@ -1740,13 +1752,13 @@
                 <c:formatCode>General</c:formatCode>
                 <c:ptCount val="9"/>
                 <c:pt idx="0">
-                  <c:v/>
+                  <c:v>3</c:v>
                 </c:pt>
                 <c:pt idx="1">
                   <c:v>1</c:v>
                 </c:pt>
                 <c:pt idx="2">
-                  <c:v>3</c:v>
+                  <c:v>2</c:v>
                 </c:pt>
                 <c:pt idx="3">
                   <c:v/>
@@ -1755,7 +1767,7 @@
                   <c:v/>
                 </c:pt>
                 <c:pt idx="5">
-                  <c:v/>
+                  <c:v>6</c:v>
                 </c:pt>
                 <c:pt idx="6">
                   <c:v/>
@@ -2193,7 +2205,7 @@
                   <c:v>10</c:v>
                 </c:pt>
                 <c:pt idx="5">
-                  <c:v>7</c:v>
+                  <c:v>10</c:v>
                 </c:pt>
                 <c:pt idx="6">
                   <c:v>110</c:v>
@@ -2304,7 +2316,7 @@
                   <c:v>2</c:v>
                 </c:pt>
                 <c:pt idx="2">
-                  <c:v>8</c:v>
+                  <c:v>9</c:v>
                 </c:pt>
                 <c:pt idx="3">
                   <c:v/>
@@ -2313,7 +2325,7 @@
                   <c:v>3</c:v>
                 </c:pt>
                 <c:pt idx="5">
-                  <c:v>13</c:v>
+                  <c:v>11</c:v>
                 </c:pt>
                 <c:pt idx="6">
                   <c:v/>
@@ -2424,7 +2436,7 @@
                   <c:v/>
                 </c:pt>
                 <c:pt idx="2">
-                  <c:v>1</c:v>
+                  <c:v/>
                 </c:pt>
                 <c:pt idx="3">
                   <c:v/>
@@ -2433,7 +2445,7 @@
                   <c:v>1</c:v>
                 </c:pt>
                 <c:pt idx="5">
-                  <c:v>2</c:v>
+                  <c:v>1</c:v>
                 </c:pt>
                 <c:pt idx="6">
                   <c:v/>
@@ -2724,16 +2736,16 @@
                 <c:formatCode>General</c:formatCode>
                 <c:ptCount val="5"/>
                 <c:pt idx="0">
-                  <c:v>18</c:v>
+                  <c:v>9</c:v>
                 </c:pt>
                 <c:pt idx="1">
-                  <c:v>77</c:v>
+                  <c:v>61</c:v>
                 </c:pt>
                 <c:pt idx="2">
-                  <c:v>32</c:v>
+                  <c:v>39</c:v>
                 </c:pt>
                 <c:pt idx="3">
-                  <c:v>17</c:v>
+                  <c:v>12</c:v>
                 </c:pt>
                 <c:pt idx="4">
                   <c:v>4</c:v>
@@ -2820,13 +2832,13 @@
                 <c:formatCode>General</c:formatCode>
                 <c:ptCount val="5"/>
                 <c:pt idx="0">
-                  <c:v>132</c:v>
+                  <c:v>140</c:v>
                 </c:pt>
                 <c:pt idx="1">
-                  <c:v>56</c:v>
+                  <c:v>60</c:v>
                 </c:pt>
                 <c:pt idx="2">
-                  <c:v>28</c:v>
+                  <c:v>11</c:v>
                 </c:pt>
                 <c:pt idx="3">
                   <c:v>13</c:v>
@@ -4152,7 +4164,7 @@
                   <c:v>153</c:v>
                 </c:pt>
                 <c:pt idx="3">
-                  <c:v>111</c:v>
+                  <c:v>110</c:v>
                 </c:pt>
                 <c:pt idx="4">
                   <c:v>17</c:v>
@@ -6895,7 +6907,7 @@
                 <a:ea typeface="Cambria" pitchFamily="34" charset="-122"/>
                 <a:cs typeface="Cambria" pitchFamily="34" charset="-120"/>
               </a:rPr>
-              <a:t>57,5%</a:t>
+              <a:t>61,3%</a:t>
             </a:r>
             <a:endParaRPr lang="en-US" sz="3400" dirty="0"/>
           </a:p>
@@ -6973,7 +6985,7 @@
                 <a:ea typeface="Cambria" pitchFamily="34" charset="-122"/>
                 <a:cs typeface="Cambria" pitchFamily="34" charset="-120"/>
               </a:rPr>
-              <a:t>73,3%</a:t>
+              <a:t>80%</a:t>
             </a:r>
             <a:endParaRPr lang="en-US" sz="3400" dirty="0"/>
           </a:p>
@@ -7051,7 +7063,7 @@
                 <a:ea typeface="Cambria" pitchFamily="34" charset="-122"/>
                 <a:cs typeface="Cambria" pitchFamily="34" charset="-120"/>
               </a:rPr>
-              <a:t>44,2%</a:t>
+              <a:t>45,3%</a:t>
             </a:r>
             <a:endParaRPr lang="en-US" sz="3400" dirty="0"/>
           </a:p>
@@ -7129,7 +7141,7 @@
                 <a:ea typeface="Cambria" pitchFamily="34" charset="-122"/>
                 <a:cs typeface="Cambria" pitchFamily="34" charset="-120"/>
               </a:rPr>
-              <a:t>70,7%</a:t>
+              <a:t>68,8%</a:t>
             </a:r>
             <a:endParaRPr lang="en-US" sz="3400" dirty="0"/>
           </a:p>
@@ -7207,7 +7219,7 @@
                 <a:ea typeface="Calibri" pitchFamily="34" charset="-122"/>
                 <a:cs typeface="Calibri" pitchFamily="34" charset="-120"/>
               </a:rPr>
-              <a:t>Corte: 18-08-2026</a:t>
+              <a:t>Corte: 25-08-2026</a:t>
             </a:r>
             <a:endParaRPr lang="en-US" sz="1100" dirty="0"/>
           </a:p>
@@ -7246,7 +7258,7 @@
                 <a:ea typeface="Calibri" pitchFamily="34" charset="-122"/>
                 <a:cs typeface="Calibri" pitchFamily="34" charset="-120"/>
               </a:rPr>
-              <a:t>Fuente: REPORTE_GERENCIAL + Listado de Puntos Punch Consolidado · Corte 18-08-2026 · Atrasos al 24-08-2026</a:t>
+              <a:t>Fuente: REPORTE_GERENCIAL + Listado de Puntos Punch Consolidado · Corte 25-08-2026 · Atrasos al 31-08-2026</a:t>
             </a:r>
             <a:endParaRPr lang="en-US" sz="850" dirty="0"/>
           </a:p>
@@ -7539,7 +7551,7 @@
                 <a:ea typeface="Calibri" pitchFamily="34" charset="-122"/>
                 <a:cs typeface="Calibri" pitchFamily="34" charset="-120"/>
               </a:rPr>
-              <a:t>Recuperar los 148 DT atrasados</a:t>
+              <a:t>Recuperar los 125 DT atrasados</a:t>
             </a:r>
             <a:endParaRPr lang="en-US" sz="1350" dirty="0"/>
           </a:p>
@@ -7581,7 +7593,7 @@
                 <a:ea typeface="Calibri" pitchFamily="34" charset="-122"/>
                 <a:cs typeface="Calibri" pitchFamily="34" charset="-120"/>
               </a:rPr>
-              <a:t>131 son P2 y 14 son P1. La mediana de atraso es de 23 días y 10 superan los 90 días.</a:t>
+              <a:t>100 son P2 y 22 son P1. La mediana de atraso es de 28 días y 10 superan los 90 días.</a:t>
             </a:r>
             <a:endParaRPr lang="en-US" sz="1100" dirty="0"/>
           </a:p>
@@ -7723,7 +7735,7 @@
                 <a:ea typeface="Calibri" pitchFamily="34" charset="-122"/>
                 <a:cs typeface="Calibri" pitchFamily="34" charset="-120"/>
               </a:rPr>
-              <a:t>CERRO VERDE/PS2: 0/3 (0%) · PISCINAS Y SEDIMENTADOR: 6/22 (27,3%). A nivel proyecto la caminata 2 va 89% con 20 ya agendadas.</a:t>
+              <a:t>CERRO VERDE/PS2: 0/3 (0%) · PISCINAS Y SEDIMENTADOR: 10/22 (45,5%). A nivel proyecto la caminata 2 va 90,8% con 8 ya agendadas.</a:t>
             </a:r>
             <a:endParaRPr lang="en-US" sz="1100" dirty="0"/>
           </a:p>
@@ -8007,7 +8019,7 @@
                 <a:ea typeface="Calibri" pitchFamily="34" charset="-122"/>
                 <a:cs typeface="Calibri" pitchFamily="34" charset="-120"/>
               </a:rPr>
-              <a:t>Concentra 112 de los 380 DT abiertos (29,5%), con 6 atrasados. Además hay 6 carpetas bajo 80% de avance que conviene cerrar en paralelo.</a:t>
+              <a:t>Concentra 110 de los 352 DT abiertos (31,3%), con 4 atrasados. Además hay 4 carpetas bajo 80% de avance que conviene cerrar en paralelo.</a:t>
             </a:r>
             <a:endParaRPr lang="en-US" sz="1100" dirty="0"/>
           </a:p>
@@ -8046,7 +8058,7 @@
                 <a:ea typeface="Calibri" pitchFamily="34" charset="-122"/>
                 <a:cs typeface="Calibri" pitchFamily="34" charset="-120"/>
               </a:rPr>
-              <a:t>Fuente: STATUS_SUBSISTEMAS_TALABRE + Detalle_de_Terminaciones · 218 subsistemas · 2.062 DT · Atrasos al 24-08-2026</a:t>
+              <a:t>Fuente: STATUS_SUBSISTEMAS_TALABRE + Detalle_de_Terminaciones · 218 subsistemas · 2.078 DT · Atrasos al 31-08-2026</a:t>
             </a:r>
             <a:endParaRPr lang="en-US" sz="850" dirty="0"/>
           </a:p>
@@ -8692,7 +8704,7 @@
                 <a:ea typeface="Cambria" pitchFamily="34" charset="-122"/>
                 <a:cs typeface="Cambria" pitchFamily="34" charset="-120"/>
               </a:rPr>
-              <a:t>58%</a:t>
+              <a:t>58,1%</a:t>
             </a:r>
             <a:endParaRPr lang="en-US" sz="3400" dirty="0"/>
           </a:p>
@@ -8770,7 +8782,7 @@
                 <a:ea typeface="Calibri" pitchFamily="34" charset="-122"/>
                 <a:cs typeface="Calibri" pitchFamily="34" charset="-120"/>
               </a:rPr>
-              <a:t>Corte: 17-08-2026   ·   Corte anterior: 10-08-2026</a:t>
+              <a:t>Corte: 24-08-2026   ·   Corte anterior: 17-08-2026</a:t>
             </a:r>
             <a:endParaRPr lang="en-US" sz="1100" dirty="0"/>
           </a:p>
@@ -8809,7 +8821,7 @@
                 <a:ea typeface="Calibri" pitchFamily="34" charset="-122"/>
                 <a:cs typeface="Calibri" pitchFamily="34" charset="-120"/>
               </a:rPr>
-              <a:t>Fuente: Estatus_Resumen_General_QAQC.xlsx · Corte 17-08-2026 · Áreas 2000/3000/4000/8000</a:t>
+              <a:t>Fuente: Estatus_Resumen_General_QAQC.xlsx · Corte 24-08-2026 · Áreas 2000/3000/4000/8000</a:t>
             </a:r>
             <a:endParaRPr lang="en-US" sz="850" dirty="0"/>
           </a:p>
@@ -9684,13 +9696,13 @@
             <a:r>
               <a:rPr lang="en-US" sz="900" b="1" dirty="0">
                 <a:solidFill>
-                  <a:srgbClr val="1F7A44"/>
-                </a:solidFill>
-                <a:latin typeface="Calibri" pitchFamily="34" charset="0"/>
-                <a:ea typeface="Calibri" pitchFamily="34" charset="-122"/>
-                <a:cs typeface="Calibri" pitchFamily="34" charset="-120"/>
-              </a:rPr>
-              <a:t>▲ +1 vs. corte anterior</a:t>
+                  <a:srgbClr val="56606E"/>
+                </a:solidFill>
+                <a:latin typeface="Calibri" pitchFamily="34" charset="0"/>
+                <a:ea typeface="Calibri" pitchFamily="34" charset="-122"/>
+                <a:cs typeface="Calibri" pitchFamily="34" charset="-120"/>
+              </a:rPr>
+              <a:t>= sin cambio vs. corte anterior</a:t>
             </a:r>
             <a:endParaRPr lang="en-US" sz="900" dirty="0"/>
           </a:p>
@@ -9783,7 +9795,7 @@
                 <a:ea typeface="Cambria" pitchFamily="34" charset="-122"/>
                 <a:cs typeface="Cambria" pitchFamily="34" charset="-120"/>
               </a:rPr>
-              <a:t>58%</a:t>
+              <a:t>58,1%</a:t>
             </a:r>
             <a:endParaRPr lang="en-US" sz="4000" dirty="0"/>
           </a:p>
@@ -9822,7 +9834,7 @@
                 <a:ea typeface="Calibri" pitchFamily="34" charset="-122"/>
                 <a:cs typeface="Calibri" pitchFamily="34" charset="-120"/>
               </a:rPr>
-              <a:t>1.154/1.988</a:t>
+              <a:t>1.156/1.988</a:t>
             </a:r>
             <a:endParaRPr lang="en-US" sz="1400" dirty="0"/>
           </a:p>
@@ -9900,7 +9912,7 @@
                 <a:ea typeface="Calibri" pitchFamily="34" charset="-122"/>
                 <a:cs typeface="Calibri" pitchFamily="34" charset="-120"/>
               </a:rPr>
-              <a:t>826 abiertos · 673 vencidos · 8 en trámite</a:t>
+              <a:t>825 abiertos · 672 vencidos · 7 en trámite</a:t>
             </a:r>
             <a:endParaRPr lang="en-US" sz="950" dirty="0"/>
           </a:p>
@@ -9933,13 +9945,13 @@
             <a:r>
               <a:rPr lang="en-US" sz="900" b="1" dirty="0">
                 <a:solidFill>
-                  <a:srgbClr val="56606E"/>
-                </a:solidFill>
-                <a:latin typeface="Calibri" pitchFamily="34" charset="0"/>
-                <a:ea typeface="Calibri" pitchFamily="34" charset="-122"/>
-                <a:cs typeface="Calibri" pitchFamily="34" charset="-120"/>
-              </a:rPr>
-              <a:t>= sin cambio vs. corte anterior</a:t>
+                  <a:srgbClr val="1F7A44"/>
+                </a:solidFill>
+                <a:latin typeface="Calibri" pitchFamily="34" charset="0"/>
+                <a:ea typeface="Calibri" pitchFamily="34" charset="-122"/>
+                <a:cs typeface="Calibri" pitchFamily="34" charset="-120"/>
+              </a:rPr>
+              <a:t>▲ +2 vs. corte anterior</a:t>
             </a:r>
             <a:endParaRPr lang="en-US" sz="900" dirty="0"/>
           </a:p>
@@ -10237,7 +10249,7 @@
                 <a:ea typeface="Calibri" pitchFamily="34" charset="-122"/>
                 <a:cs typeface="Calibri" pitchFamily="34" charset="-120"/>
               </a:rPr>
-              <a:t>Ningún P1 cerrado desde el corte anterior; 826 abiertos, de los cuales 673 superaron su fecha de vencimiento (+6 en el período). El área 3000 concentra 703 (85,1%).</a:t>
+              <a:t>+2 P1 cerrado desde el corte anterior; 825 abiertos, de los cuales 672 superaron su fecha de vencimiento. El área 3000 concentra 702 (85,1%).</a:t>
             </a:r>
             <a:endParaRPr lang="en-US" sz="1250" dirty="0"/>
           </a:p>
@@ -10276,7 +10288,7 @@
                 <a:ea typeface="Calibri" pitchFamily="34" charset="-122"/>
                 <a:cs typeface="Calibri" pitchFamily="34" charset="-120"/>
               </a:rPr>
-              <a:t>Fuente: Estatus_Resumen_General_QAQC.xlsx · Corte 17-08-2026 · Áreas 2000/3000/4000/8000</a:t>
+              <a:t>Fuente: Estatus_Resumen_General_QAQC.xlsx · Corte 24-08-2026 · Áreas 2000/3000/4000/8000</a:t>
             </a:r>
             <a:endParaRPr lang="en-US" sz="850" dirty="0"/>
           </a:p>
@@ -11018,7 +11030,7 @@
                 <a:ea typeface="Calibri" pitchFamily="34" charset="-122"/>
                 <a:cs typeface="Calibri" pitchFamily="34" charset="-120"/>
               </a:rPr>
-              <a:t>92,8%</a:t>
+              <a:t>93,2%</a:t>
             </a:r>
             <a:endParaRPr lang="en-US" sz="1300" dirty="0"/>
           </a:p>
@@ -11434,7 +11446,7 @@
                 <a:ea typeface="Calibri" pitchFamily="34" charset="-122"/>
                 <a:cs typeface="Calibri" pitchFamily="34" charset="-120"/>
               </a:rPr>
-              <a:t>703 (604)</a:t>
+              <a:t>702 (603)</a:t>
             </a:r>
             <a:endParaRPr lang="en-US" sz="1300" dirty="0"/>
           </a:p>
@@ -12330,7 +12342,7 @@
                 <a:ea typeface="Calibri" pitchFamily="34" charset="-122"/>
                 <a:cs typeface="Calibri" pitchFamily="34" charset="-120"/>
               </a:rPr>
-              <a:t>Fuente: Estatus_Resumen_General_QAQC.xlsx · Corte 17-08-2026 · Áreas 2000/3000/4000/8000</a:t>
+              <a:t>Fuente: Estatus_Resumen_General_QAQC.xlsx · Corte 24-08-2026 · Áreas 2000/3000/4000/8000</a:t>
             </a:r>
             <a:endParaRPr lang="en-US" sz="850" dirty="0"/>
           </a:p>
@@ -12974,7 +12986,7 @@
                 <a:ea typeface="Calibri" pitchFamily="34" charset="-122"/>
                 <a:cs typeface="Calibri" pitchFamily="34" charset="-120"/>
               </a:rPr>
-              <a:t>Fuente: Estatus_Resumen_General_QAQC.xlsx · Corte 17-08-2026 · Áreas 2000/3000/4000/8000</a:t>
+              <a:t>Fuente: Estatus_Resumen_General_QAQC.xlsx · Corte 24-08-2026 · Áreas 2000/3000/4000/8000</a:t>
             </a:r>
             <a:endParaRPr lang="en-US" sz="850" dirty="0"/>
           </a:p>
@@ -13402,45 +13414,6 @@
         </p:nvSpPr>
         <p:spPr>
           <a:xfrm>
-            <a:off x="9509760" y="2450592"/>
-            <a:ext cx="914400" cy="566928"/>
-          </a:xfrm>
-          <a:prstGeom prst="rect">
-            <a:avLst/>
-          </a:prstGeom>
-          <a:noFill/>
-          <a:ln/>
-        </p:spPr>
-        <p:txBody>
-          <a:bodyPr wrap="square" lIns="0" tIns="0" rIns="0" bIns="0" rtlCol="0" anchor="ctr"/>
-          <a:lstStyle/>
-          <a:p>
-            <a:pPr algn="r" indent="0" marL="0">
-              <a:buNone/>
-            </a:pPr>
-            <a:r>
-              <a:rPr lang="en-US" sz="950" b="1" dirty="0">
-                <a:solidFill>
-                  <a:srgbClr val="1F7A44"/>
-                </a:solidFill>
-                <a:latin typeface="Calibri" pitchFamily="34" charset="0"/>
-                <a:ea typeface="Calibri" pitchFamily="34" charset="-122"/>
-                <a:cs typeface="Calibri" pitchFamily="34" charset="-120"/>
-              </a:rPr>
-              <a:t>▲ +1</a:t>
-            </a:r>
-            <a:endParaRPr lang="en-US" sz="950" dirty="0"/>
-          </a:p>
-        </p:txBody>
-      </p:sp>
-      <p:sp>
-        <p:nvSpPr>
-          <p:cNvPr id="13" name="Text 9"/>
-          <p:cNvSpPr/>
-          <p:nvPr/>
-        </p:nvSpPr>
-        <p:spPr>
-          <a:xfrm>
             <a:off x="10469880" y="2450592"/>
             <a:ext cx="868680" cy="566928"/>
           </a:xfrm>
@@ -13474,7 +13447,7 @@
       </p:sp>
       <p:sp>
         <p:nvSpPr>
-          <p:cNvPr id="14" name="Shape 10"/>
+          <p:cNvPr id="13" name="Shape 9"/>
           <p:cNvSpPr/>
           <p:nvPr/>
         </p:nvSpPr>
@@ -13496,7 +13469,7 @@
       </p:sp>
       <p:sp>
         <p:nvSpPr>
-          <p:cNvPr id="15" name="Shape 11"/>
+          <p:cNvPr id="14" name="Shape 10"/>
           <p:cNvSpPr/>
           <p:nvPr/>
         </p:nvSpPr>
@@ -13516,7 +13489,7 @@
       </p:sp>
       <p:sp>
         <p:nvSpPr>
-          <p:cNvPr id="16" name="Text 12"/>
+          <p:cNvPr id="15" name="Text 11"/>
           <p:cNvSpPr/>
           <p:nvPr/>
         </p:nvSpPr>
@@ -13555,46 +13528,7 @@
       </p:sp>
       <p:sp>
         <p:nvSpPr>
-          <p:cNvPr id="17" name="Text 13"/>
-          <p:cNvSpPr/>
-          <p:nvPr/>
-        </p:nvSpPr>
-        <p:spPr>
-          <a:xfrm>
-            <a:off x="9509760" y="3072384"/>
-            <a:ext cx="914400" cy="566928"/>
-          </a:xfrm>
-          <a:prstGeom prst="rect">
-            <a:avLst/>
-          </a:prstGeom>
-          <a:noFill/>
-          <a:ln/>
-        </p:spPr>
-        <p:txBody>
-          <a:bodyPr wrap="square" lIns="0" tIns="0" rIns="0" bIns="0" rtlCol="0" anchor="ctr"/>
-          <a:lstStyle/>
-          <a:p>
-            <a:pPr algn="r" indent="0" marL="0">
-              <a:buNone/>
-            </a:pPr>
-            <a:r>
-              <a:rPr lang="en-US" sz="950" b="1" dirty="0">
-                <a:solidFill>
-                  <a:srgbClr val="1F7A44"/>
-                </a:solidFill>
-                <a:latin typeface="Calibri" pitchFamily="34" charset="0"/>
-                <a:ea typeface="Calibri" pitchFamily="34" charset="-122"/>
-                <a:cs typeface="Calibri" pitchFamily="34" charset="-120"/>
-              </a:rPr>
-              <a:t>▲ +1</a:t>
-            </a:r>
-            <a:endParaRPr lang="en-US" sz="950" dirty="0"/>
-          </a:p>
-        </p:txBody>
-      </p:sp>
-      <p:sp>
-        <p:nvSpPr>
-          <p:cNvPr id="18" name="Text 14"/>
+          <p:cNvPr id="16" name="Text 12"/>
           <p:cNvSpPr/>
           <p:nvPr/>
         </p:nvSpPr>
@@ -13633,7 +13567,7 @@
       </p:sp>
       <p:sp>
         <p:nvSpPr>
-          <p:cNvPr id="19" name="Shape 15"/>
+          <p:cNvPr id="17" name="Shape 13"/>
           <p:cNvSpPr/>
           <p:nvPr/>
         </p:nvSpPr>
@@ -13655,7 +13589,7 @@
       </p:sp>
       <p:sp>
         <p:nvSpPr>
-          <p:cNvPr id="20" name="Shape 16"/>
+          <p:cNvPr id="18" name="Shape 14"/>
           <p:cNvSpPr/>
           <p:nvPr/>
         </p:nvSpPr>
@@ -13675,7 +13609,7 @@
       </p:sp>
       <p:sp>
         <p:nvSpPr>
-          <p:cNvPr id="21" name="Text 17"/>
+          <p:cNvPr id="19" name="Text 15"/>
           <p:cNvSpPr/>
           <p:nvPr/>
         </p:nvSpPr>
@@ -13714,7 +13648,7 @@
       </p:sp>
       <p:sp>
         <p:nvSpPr>
-          <p:cNvPr id="22" name="Text 18"/>
+          <p:cNvPr id="20" name="Text 16"/>
           <p:cNvSpPr/>
           <p:nvPr/>
         </p:nvSpPr>
@@ -13753,7 +13687,7 @@
       </p:sp>
       <p:sp>
         <p:nvSpPr>
-          <p:cNvPr id="23" name="Shape 19"/>
+          <p:cNvPr id="21" name="Shape 17"/>
           <p:cNvSpPr/>
           <p:nvPr/>
         </p:nvSpPr>
@@ -13775,7 +13709,7 @@
       </p:sp>
       <p:sp>
         <p:nvSpPr>
-          <p:cNvPr id="24" name="Shape 20"/>
+          <p:cNvPr id="22" name="Shape 18"/>
           <p:cNvSpPr/>
           <p:nvPr/>
         </p:nvSpPr>
@@ -13795,7 +13729,7 @@
       </p:sp>
       <p:sp>
         <p:nvSpPr>
-          <p:cNvPr id="25" name="Text 21"/>
+          <p:cNvPr id="23" name="Text 19"/>
           <p:cNvSpPr/>
           <p:nvPr/>
         </p:nvSpPr>
@@ -13834,7 +13768,7 @@
       </p:sp>
       <p:sp>
         <p:nvSpPr>
-          <p:cNvPr id="26" name="Text 22"/>
+          <p:cNvPr id="24" name="Text 20"/>
           <p:cNvSpPr/>
           <p:nvPr/>
         </p:nvSpPr>
@@ -13873,7 +13807,7 @@
       </p:sp>
       <p:sp>
         <p:nvSpPr>
-          <p:cNvPr id="27" name="Shape 23"/>
+          <p:cNvPr id="25" name="Shape 21"/>
           <p:cNvSpPr/>
           <p:nvPr/>
         </p:nvSpPr>
@@ -13895,7 +13829,7 @@
       </p:sp>
       <p:sp>
         <p:nvSpPr>
-          <p:cNvPr id="28" name="Shape 24"/>
+          <p:cNvPr id="26" name="Shape 22"/>
           <p:cNvSpPr/>
           <p:nvPr/>
         </p:nvSpPr>
@@ -13915,7 +13849,7 @@
       </p:sp>
       <p:sp>
         <p:nvSpPr>
-          <p:cNvPr id="29" name="Text 25"/>
+          <p:cNvPr id="27" name="Text 23"/>
           <p:cNvSpPr/>
           <p:nvPr/>
         </p:nvSpPr>
@@ -13954,7 +13888,7 @@
       </p:sp>
       <p:sp>
         <p:nvSpPr>
-          <p:cNvPr id="30" name="Text 26"/>
+          <p:cNvPr id="28" name="Text 24"/>
           <p:cNvSpPr/>
           <p:nvPr/>
         </p:nvSpPr>
@@ -13993,7 +13927,7 @@
       </p:sp>
       <p:sp>
         <p:nvSpPr>
-          <p:cNvPr id="31" name="Text 27"/>
+          <p:cNvPr id="29" name="Text 25"/>
           <p:cNvSpPr/>
           <p:nvPr/>
         </p:nvSpPr>
@@ -14032,7 +13966,7 @@
       </p:sp>
       <p:sp>
         <p:nvSpPr>
-          <p:cNvPr id="32" name="Text 28"/>
+          <p:cNvPr id="30" name="Text 26"/>
           <p:cNvSpPr/>
           <p:nvPr/>
         </p:nvSpPr>
@@ -14063,7 +13997,7 @@
                 <a:ea typeface="Calibri" pitchFamily="34" charset="-122"/>
                 <a:cs typeface="Calibri" pitchFamily="34" charset="-120"/>
               </a:rPr>
-              <a:t>Fuente: Estatus_Resumen_General_QAQC.xlsx · Corte 17-08-2026 · Áreas 2000/3000/4000/8000</a:t>
+              <a:t>Fuente: Estatus_Resumen_General_QAQC.xlsx · Corte 24-08-2026 · Áreas 2000/3000/4000/8000</a:t>
             </a:r>
             <a:endParaRPr lang="en-US" sz="850" dirty="0"/>
           </a:p>
@@ -14071,7 +14005,7 @@
       </p:sp>
       <p:sp>
         <p:nvSpPr>
-          <p:cNvPr id="33" name="Text 29"/>
+          <p:cNvPr id="31" name="Text 27"/>
           <p:cNvSpPr/>
           <p:nvPr/>
         </p:nvSpPr>
@@ -14110,7 +14044,7 @@
       </p:sp>
       <p:sp>
         <p:nvSpPr>
-          <p:cNvPr id="34" name="Text 30"/>
+          <p:cNvPr id="32" name="Text 28"/>
           <p:cNvSpPr/>
           <p:nvPr/>
         </p:nvSpPr>
@@ -14314,7 +14248,7 @@
                 <a:ea typeface="Calibri" pitchFamily="34" charset="-122"/>
                 <a:cs typeface="Calibri" pitchFamily="34" charset="-120"/>
               </a:rPr>
-              <a:t>1.988 P1 levantados; 58% cerrados. El pendiente se concentra en Piping, Eléctrica, Instrumentación y Control, y físicamente en el área 3000.</a:t>
+              <a:t>1.988 P1 levantados; 58,1% cerrados. El pendiente se concentra en Piping, Eléctrica, Instrumentación y Control, y físicamente en el área 3000.</a:t>
             </a:r>
             <a:endParaRPr lang="en-US" sz="1350" dirty="0"/>
           </a:p>
@@ -14446,7 +14380,7 @@
                 <a:ea typeface="Cambria" pitchFamily="34" charset="-122"/>
                 <a:cs typeface="Cambria" pitchFamily="34" charset="-120"/>
               </a:rPr>
-              <a:t>58%</a:t>
+              <a:t>58,1%</a:t>
             </a:r>
             <a:endParaRPr lang="en-US" sz="1900" dirty="0"/>
           </a:p>
@@ -14561,7 +14495,7 @@
                 <a:ea typeface="Calibri" pitchFamily="34" charset="-122"/>
                 <a:cs typeface="Calibri" pitchFamily="34" charset="-120"/>
               </a:rPr>
-              <a:t>1.154</a:t>
+              <a:t>1.156</a:t>
             </a:r>
             <a:endParaRPr lang="en-US" sz="1100" dirty="0"/>
           </a:p>
@@ -14659,7 +14593,7 @@
                 <a:ea typeface="Calibri" pitchFamily="34" charset="-122"/>
                 <a:cs typeface="Calibri" pitchFamily="34" charset="-120"/>
               </a:rPr>
-              <a:t>826</a:t>
+              <a:t>825</a:t>
             </a:r>
             <a:endParaRPr lang="en-US" sz="1100" dirty="0"/>
           </a:p>
@@ -14757,7 +14691,7 @@
                 <a:ea typeface="Calibri" pitchFamily="34" charset="-122"/>
                 <a:cs typeface="Calibri" pitchFamily="34" charset="-120"/>
               </a:rPr>
-              <a:t>8</a:t>
+              <a:t>7</a:t>
             </a:r>
             <a:endParaRPr lang="en-US" sz="1100" dirty="0"/>
           </a:p>
@@ -14840,7 +14774,7 @@
                 <a:ea typeface="Calibri" pitchFamily="34" charset="-122"/>
                 <a:cs typeface="Calibri" pitchFamily="34" charset="-120"/>
               </a:rPr>
-              <a:t>703 de 826 P1 abiertos (85,1%) están en el área 3000. Áreas 2000 y 8000 sobre 90% de cierre.</a:t>
+              <a:t>702 de 825 P1 abiertos (85,1%) están en el área 3000. Áreas 2000 y 8000 sobre 90% de cierre.</a:t>
             </a:r>
             <a:endParaRPr lang="en-US" sz="1150" dirty="0"/>
           </a:p>
@@ -14879,7 +14813,7 @@
                 <a:ea typeface="Calibri" pitchFamily="34" charset="-122"/>
                 <a:cs typeface="Calibri" pitchFamily="34" charset="-120"/>
               </a:rPr>
-              <a:t>Fuente: Estatus_Resumen_General_QAQC.xlsx · Corte 17-08-2026 · Áreas 2000/3000/4000/8000</a:t>
+              <a:t>Fuente: Estatus_Resumen_General_QAQC.xlsx · Corte 24-08-2026 · Áreas 2000/3000/4000/8000</a:t>
             </a:r>
             <a:endParaRPr lang="en-US" sz="850" dirty="0"/>
           </a:p>
@@ -15395,7 +15329,7 @@
                 <a:ea typeface="Calibri" pitchFamily="34" charset="-122"/>
                 <a:cs typeface="Calibri" pitchFamily="34" charset="-120"/>
               </a:rPr>
-              <a:t>703 P1 abiertos (85,1% del total) y 41 caminatas 100% pendientes. Es la ruta crítica: sin esta área no mejora ningún indicador global.</a:t>
+              <a:t>702 P1 abiertos (85,1% del total) y 41 caminatas 100% pendientes. Es la ruta crítica: sin esta área no mejora ningún indicador global.</a:t>
             </a:r>
             <a:endParaRPr lang="en-US" sz="1150" dirty="0"/>
           </a:p>
@@ -15495,7 +15429,7 @@
                 <a:ea typeface="Calibri" pitchFamily="34" charset="-122"/>
                 <a:cs typeface="Calibri" pitchFamily="34" charset="-120"/>
               </a:rPr>
-              <a:t>Recuperar los 673 P1 vencidos</a:t>
+              <a:t>Recuperar los 672 P1 vencidos</a:t>
             </a:r>
             <a:endParaRPr lang="en-US" sz="1500" dirty="0"/>
           </a:p>
@@ -15718,7 +15652,7 @@
                 <a:ea typeface="Calibri" pitchFamily="34" charset="-122"/>
                 <a:cs typeface="Calibri" pitchFamily="34" charset="-120"/>
               </a:rPr>
-              <a:t>Fuente: Estatus_Resumen_General_QAQC.xlsx · Corte 17-08-2026 · Áreas 2000/3000/4000/8000</a:t>
+              <a:t>Fuente: Estatus_Resumen_General_QAQC.xlsx · Corte 24-08-2026 · Áreas 2000/3000/4000/8000</a:t>
             </a:r>
             <a:endParaRPr lang="en-US" sz="850" dirty="0"/>
           </a:p>
@@ -16023,7 +15957,7 @@
                 <a:ea typeface="Cambria" pitchFamily="34" charset="-122"/>
                 <a:cs typeface="Cambria" pitchFamily="34" charset="-120"/>
               </a:rPr>
-              <a:t>57,5%</a:t>
+              <a:t>61,3%</a:t>
             </a:r>
             <a:endParaRPr lang="en-US" sz="3800" dirty="0"/>
           </a:p>
@@ -16062,7 +15996,7 @@
                 <a:ea typeface="Calibri" pitchFamily="34" charset="-122"/>
                 <a:cs typeface="Calibri" pitchFamily="34" charset="-120"/>
               </a:rPr>
-              <a:t>46/80</a:t>
+              <a:t>49/80</a:t>
             </a:r>
             <a:endParaRPr lang="en-US" sz="1400" dirty="0"/>
           </a:p>
@@ -16143,7 +16077,7 @@
                 <a:ea typeface="Calibri" pitchFamily="34" charset="-122"/>
                 <a:cs typeface="Calibri" pitchFamily="34" charset="-120"/>
               </a:rPr>
-              <a:t>34 subsistemas por caminar</a:t>
+              <a:t>31 subsistemas por caminar</a:t>
             </a:r>
             <a:endParaRPr lang="en-US" sz="950" dirty="0"/>
           </a:p>
@@ -16236,7 +16170,7 @@
                 <a:ea typeface="Cambria" pitchFamily="34" charset="-122"/>
                 <a:cs typeface="Cambria" pitchFamily="34" charset="-120"/>
               </a:rPr>
-              <a:t>73,3%</a:t>
+              <a:t>80%</a:t>
             </a:r>
             <a:endParaRPr lang="en-US" sz="3800" dirty="0"/>
           </a:p>
@@ -16275,7 +16209,7 @@
                 <a:ea typeface="Calibri" pitchFamily="34" charset="-122"/>
                 <a:cs typeface="Calibri" pitchFamily="34" charset="-120"/>
               </a:rPr>
-              <a:t>11/15</a:t>
+              <a:t>12/15</a:t>
             </a:r>
             <a:endParaRPr lang="en-US" sz="1400" dirty="0"/>
           </a:p>
@@ -16356,7 +16290,7 @@
                 <a:ea typeface="Calibri" pitchFamily="34" charset="-122"/>
                 <a:cs typeface="Calibri" pitchFamily="34" charset="-120"/>
               </a:rPr>
-              <a:t>4 facilities por caminar</a:t>
+              <a:t>3 facilities por caminar</a:t>
             </a:r>
             <a:endParaRPr lang="en-US" sz="950" dirty="0"/>
           </a:p>
@@ -16449,7 +16383,7 @@
                 <a:ea typeface="Cambria" pitchFamily="34" charset="-122"/>
                 <a:cs typeface="Cambria" pitchFamily="34" charset="-120"/>
               </a:rPr>
-              <a:t>44,2%</a:t>
+              <a:t>45,3%</a:t>
             </a:r>
             <a:endParaRPr lang="en-US" sz="3800" dirty="0"/>
           </a:p>
@@ -16488,7 +16422,7 @@
                 <a:ea typeface="Calibri" pitchFamily="34" charset="-122"/>
                 <a:cs typeface="Calibri" pitchFamily="34" charset="-120"/>
               </a:rPr>
-              <a:t>42/95</a:t>
+              <a:t>43/95</a:t>
             </a:r>
             <a:endParaRPr lang="en-US" sz="1400" dirty="0"/>
           </a:p>
@@ -16569,7 +16503,7 @@
                 <a:ea typeface="Calibri" pitchFamily="34" charset="-122"/>
                 <a:cs typeface="Calibri" pitchFamily="34" charset="-120"/>
               </a:rPr>
-              <a:t>22 aprobadas · 16 en revisión · 4 rechazadas</a:t>
+              <a:t>28 aprobadas · 13 en revisión · 2 rechazadas</a:t>
             </a:r>
             <a:endParaRPr lang="en-US" sz="950" dirty="0"/>
           </a:p>
@@ -16662,7 +16596,7 @@
                 <a:ea typeface="Cambria" pitchFamily="34" charset="-122"/>
                 <a:cs typeface="Cambria" pitchFamily="34" charset="-120"/>
               </a:rPr>
-              <a:t>70,7%</a:t>
+              <a:t>68,8%</a:t>
             </a:r>
             <a:endParaRPr lang="en-US" sz="3800" dirty="0"/>
           </a:p>
@@ -16701,7 +16635,7 @@
                 <a:ea typeface="Calibri" pitchFamily="34" charset="-122"/>
                 <a:cs typeface="Calibri" pitchFamily="34" charset="-120"/>
               </a:rPr>
-              <a:t>676/956</a:t>
+              <a:t>714/1.038</a:t>
             </a:r>
             <a:endParaRPr lang="en-US" sz="1400" dirty="0"/>
           </a:p>
@@ -16782,7 +16716,7 @@
                 <a:ea typeface="Calibri" pitchFamily="34" charset="-122"/>
                 <a:cs typeface="Calibri" pitchFamily="34" charset="-120"/>
               </a:rPr>
-              <a:t>280 abiertos · 8 atrasados</a:t>
+              <a:t>324 abiertos · 8 atrasados</a:t>
             </a:r>
             <a:endParaRPr lang="en-US" sz="950" dirty="0"/>
           </a:p>
@@ -16922,7 +16856,7 @@
                 <a:ea typeface="Calibri" pitchFamily="34" charset="-122"/>
                 <a:cs typeface="Calibri" pitchFamily="34" charset="-120"/>
               </a:rPr>
-              <a:t>1.092 de 1.596 ítems cerrados (68,4%); de los 504 abiertos, 15 ya pasaron su fecha requerida de cierre (3%).</a:t>
+              <a:t>1.169 de 1.722 ítems cerrados (67,9%); de los 553 abiertos, 14 ya pasaron su fecha requerida de cierre (2,5%).</a:t>
             </a:r>
             <a:endParaRPr lang="en-US" sz="1150" dirty="0"/>
           </a:p>
@@ -17001,7 +16935,7 @@
                 <a:ea typeface="Calibri" pitchFamily="34" charset="-122"/>
                 <a:cs typeface="Calibri" pitchFamily="34" charset="-120"/>
               </a:rPr>
-              <a:t>Operables 46/80 por Caminata 2 (57,5%); Facility 11/15 por Caminata 1 (73,3%).</a:t>
+              <a:t>Operables 49/80 por Caminata 2 (61,3%); Facility 12/15 por Caminata 1 (80%).</a:t>
             </a:r>
             <a:endParaRPr lang="en-US" sz="1150" dirty="0"/>
           </a:p>
@@ -17063,7 +16997,7 @@
                 <a:ea typeface="Calibri" pitchFamily="34" charset="-122"/>
                 <a:cs typeface="Calibri" pitchFamily="34" charset="-120"/>
               </a:rPr>
-              <a:t>Las carpetas están a 44,2% de entrega y el cuello está en el armado interno.  </a:t>
+              <a:t>Las carpetas están a 45,3% de entrega y el cuello está en el armado interno.  </a:t>
             </a:r>
             <a:pPr indent="0" marL="0">
               <a:lnSpc>
@@ -17080,7 +17014,7 @@
                 <a:ea typeface="Calibri" pitchFamily="34" charset="-122"/>
                 <a:cs typeface="Calibri" pitchFamily="34" charset="-120"/>
               </a:rPr>
-              <a:t>42 entregadas de 95: 22 aprobadas, 16 en revisión y 4 rechazadas. Quedan 15 en preparación y 38 sin iniciar.</a:t>
+              <a:t>43 entregadas de 95: 28 aprobadas, 13 en revisión y 2 rechazadas. Quedan 18 en preparación y 34 sin iniciar.</a:t>
             </a:r>
             <a:endParaRPr lang="en-US" sz="1150" dirty="0"/>
           </a:p>
@@ -17159,7 +17093,7 @@
                 <a:ea typeface="Calibri" pitchFamily="34" charset="-122"/>
                 <a:cs typeface="Calibri" pitchFamily="34" charset="-120"/>
               </a:rPr>
-              <a:t>164 de los 280 P1 abiertos (58,6%), con 3 atrasados.</a:t>
+              <a:t>166 de los 324 P1 abiertos (51,2%), con 6 atrasados.</a:t>
             </a:r>
             <a:endParaRPr lang="en-US" sz="1150" dirty="0"/>
           </a:p>
@@ -17198,7 +17132,7 @@
                 <a:ea typeface="Calibri" pitchFamily="34" charset="-122"/>
                 <a:cs typeface="Calibri" pitchFamily="34" charset="-120"/>
               </a:rPr>
-              <a:t>Fuente: REPORTE_GERENCIAL + Listado de Puntos Punch Consolidado · Corte 18-08-2026 · Atrasos al 24-08-2026</a:t>
+              <a:t>Fuente: REPORTE_GERENCIAL + Listado de Puntos Punch Consolidado · Corte 25-08-2026 · Atrasos al 31-08-2026</a:t>
             </a:r>
             <a:endParaRPr lang="en-US" sz="850" dirty="0"/>
           </a:p>
@@ -17651,7 +17585,7 @@
                 <a:ea typeface="Calibri" pitchFamily="34" charset="-122"/>
                 <a:cs typeface="Calibri" pitchFamily="34" charset="-120"/>
               </a:rPr>
-              <a:t>23,2%</a:t>
+              <a:t>29,5%</a:t>
             </a:r>
             <a:endParaRPr lang="en-US" sz="1100" dirty="0"/>
           </a:p>
@@ -17690,7 +17624,7 @@
                 <a:ea typeface="Cambria" pitchFamily="34" charset="-122"/>
                 <a:cs typeface="Cambria" pitchFamily="34" charset="-120"/>
               </a:rPr>
-              <a:t>22</a:t>
+              <a:t>28</a:t>
             </a:r>
             <a:endParaRPr lang="en-US" sz="2200" dirty="0"/>
           </a:p>
@@ -17810,7 +17744,7 @@
                 <a:ea typeface="Calibri" pitchFamily="34" charset="-122"/>
                 <a:cs typeface="Calibri" pitchFamily="34" charset="-120"/>
               </a:rPr>
-              <a:t>16,8%</a:t>
+              <a:t>13,7%</a:t>
             </a:r>
             <a:endParaRPr lang="en-US" sz="1100" dirty="0"/>
           </a:p>
@@ -17849,7 +17783,7 @@
                 <a:ea typeface="Cambria" pitchFamily="34" charset="-122"/>
                 <a:cs typeface="Cambria" pitchFamily="34" charset="-120"/>
               </a:rPr>
-              <a:t>16</a:t>
+              <a:t>13</a:t>
             </a:r>
             <a:endParaRPr lang="en-US" sz="2200" dirty="0"/>
           </a:p>
@@ -17969,7 +17903,7 @@
                 <a:ea typeface="Calibri" pitchFamily="34" charset="-122"/>
                 <a:cs typeface="Calibri" pitchFamily="34" charset="-120"/>
               </a:rPr>
-              <a:t>4,2%</a:t>
+              <a:t>2,1%</a:t>
             </a:r>
             <a:endParaRPr lang="en-US" sz="1100" dirty="0"/>
           </a:p>
@@ -18008,7 +17942,7 @@
                 <a:ea typeface="Cambria" pitchFamily="34" charset="-122"/>
                 <a:cs typeface="Cambria" pitchFamily="34" charset="-120"/>
               </a:rPr>
-              <a:t>4</a:t>
+              <a:t>2</a:t>
             </a:r>
             <a:endParaRPr lang="en-US" sz="2200" dirty="0"/>
           </a:p>
@@ -18128,7 +18062,7 @@
                 <a:ea typeface="Calibri" pitchFamily="34" charset="-122"/>
                 <a:cs typeface="Calibri" pitchFamily="34" charset="-120"/>
               </a:rPr>
-              <a:t>15,8%</a:t>
+              <a:t>18,9%</a:t>
             </a:r>
             <a:endParaRPr lang="en-US" sz="1100" dirty="0"/>
           </a:p>
@@ -18167,7 +18101,7 @@
                 <a:ea typeface="Cambria" pitchFamily="34" charset="-122"/>
                 <a:cs typeface="Cambria" pitchFamily="34" charset="-120"/>
               </a:rPr>
-              <a:t>15</a:t>
+              <a:t>18</a:t>
             </a:r>
             <a:endParaRPr lang="en-US" sz="2200" dirty="0"/>
           </a:p>
@@ -18287,7 +18221,7 @@
                 <a:ea typeface="Calibri" pitchFamily="34" charset="-122"/>
                 <a:cs typeface="Calibri" pitchFamily="34" charset="-120"/>
               </a:rPr>
-              <a:t>40%</a:t>
+              <a:t>35,8%</a:t>
             </a:r>
             <a:endParaRPr lang="en-US" sz="1100" dirty="0"/>
           </a:p>
@@ -18326,7 +18260,7 @@
                 <a:ea typeface="Cambria" pitchFamily="34" charset="-122"/>
                 <a:cs typeface="Cambria" pitchFamily="34" charset="-120"/>
               </a:rPr>
-              <a:t>38</a:t>
+              <a:t>34</a:t>
             </a:r>
             <a:endParaRPr lang="en-US" sz="2200" dirty="0"/>
           </a:p>
@@ -18368,7 +18302,7 @@
                 <a:ea typeface="Calibri" pitchFamily="34" charset="-122"/>
                 <a:cs typeface="Calibri" pitchFamily="34" charset="-120"/>
               </a:rPr>
-              <a:t>42 carpetas ya están en manos del cliente (44,2%) y 0 subsistemas tienen tarjeta verde. El grueso del pendiente todavía no sale de Besalco.</a:t>
+              <a:t>43 carpetas ya están en manos del cliente (45,3%) y 0 subsistemas tienen tarjeta verde. El grueso del pendiente todavía no sale de Besalco.</a:t>
             </a:r>
             <a:endParaRPr lang="en-US" sz="1000" dirty="0"/>
           </a:p>
@@ -18407,7 +18341,7 @@
                 <a:ea typeface="Calibri" pitchFamily="34" charset="-122"/>
                 <a:cs typeface="Calibri" pitchFamily="34" charset="-120"/>
               </a:rPr>
-              <a:t>Fuente: REPORTE_GERENCIAL + Listado de Puntos Punch Consolidado · Corte 18-08-2026 · Atrasos al 24-08-2026</a:t>
+              <a:t>Fuente: REPORTE_GERENCIAL + Listado de Puntos Punch Consolidado · Corte 25-08-2026 · Atrasos al 31-08-2026</a:t>
             </a:r>
             <a:endParaRPr lang="en-US" sz="850" dirty="0"/>
           </a:p>
@@ -18658,7 +18592,7 @@
                 <a:ea typeface="Calibri" pitchFamily="34" charset="-122"/>
                 <a:cs typeface="Calibri" pitchFamily="34" charset="-120"/>
               </a:rPr>
-              <a:t>956 P1 levantados; 70,7% cerrados. Atrasado = ítem abierto cuya fecha requerida de cierre ya venció al 24-08-2026.</a:t>
+              <a:t>1.038 P1 levantados; 68,8% cerrados. Atrasado = ítem abierto cuya fecha requerida de cierre ya venció al 31-08-2026.</a:t>
             </a:r>
             <a:endParaRPr lang="en-US" sz="1350" dirty="0"/>
           </a:p>
@@ -18790,7 +18724,7 @@
                 <a:ea typeface="Cambria" pitchFamily="34" charset="-122"/>
                 <a:cs typeface="Cambria" pitchFamily="34" charset="-120"/>
               </a:rPr>
-              <a:t>70,7%</a:t>
+              <a:t>68,8%</a:t>
             </a:r>
             <a:endParaRPr lang="en-US" sz="1900" dirty="0"/>
           </a:p>
@@ -18905,7 +18839,7 @@
                 <a:ea typeface="Calibri" pitchFamily="34" charset="-122"/>
                 <a:cs typeface="Calibri" pitchFamily="34" charset="-120"/>
               </a:rPr>
-              <a:t>676</a:t>
+              <a:t>714</a:t>
             </a:r>
             <a:endParaRPr lang="en-US" sz="1100" dirty="0"/>
           </a:p>
@@ -19101,7 +19035,7 @@
                 <a:ea typeface="Calibri" pitchFamily="34" charset="-122"/>
                 <a:cs typeface="Calibri" pitchFamily="34" charset="-120"/>
               </a:rPr>
-              <a:t>272</a:t>
+              <a:t>316</a:t>
             </a:r>
             <a:endParaRPr lang="en-US" sz="1100" dirty="0"/>
           </a:p>
@@ -19184,7 +19118,7 @@
                 <a:ea typeface="Calibri" pitchFamily="34" charset="-122"/>
                 <a:cs typeface="Calibri" pitchFamily="34" charset="-120"/>
               </a:rPr>
-              <a:t>Mediana de 4 días vencidos; el más antiguo lleva 4. 15 entre 1-30 días.</a:t>
+              <a:t>Mediana de 11 días vencidos; el más antiguo lleva 11. 14 entre 1-30 días.</a:t>
             </a:r>
             <a:endParaRPr lang="en-US" sz="1150" dirty="0"/>
           </a:p>
@@ -19223,7 +19157,7 @@
                 <a:ea typeface="Calibri" pitchFamily="34" charset="-122"/>
                 <a:cs typeface="Calibri" pitchFamily="34" charset="-120"/>
               </a:rPr>
-              <a:t>Fuente: REPORTE_GERENCIAL + Listado de Puntos Punch Consolidado · Corte 18-08-2026 · Atrasos al 24-08-2026</a:t>
+              <a:t>Fuente: REPORTE_GERENCIAL + Listado de Puntos Punch Consolidado · Corte 25-08-2026 · Atrasos al 31-08-2026</a:t>
             </a:r>
             <a:endParaRPr lang="en-US" sz="850" dirty="0"/>
           </a:p>
@@ -19555,7 +19489,7 @@
                 <a:ea typeface="Calibri" pitchFamily="34" charset="-122"/>
                 <a:cs typeface="Calibri" pitchFamily="34" charset="-120"/>
               </a:rPr>
-              <a:t>Recuperar los 15 ítems atrasados</a:t>
+              <a:t>Recuperar los 14 ítems atrasados</a:t>
             </a:r>
             <a:endParaRPr lang="en-US" sz="1400" dirty="0"/>
           </a:p>
@@ -19597,7 +19531,7 @@
                 <a:ea typeface="Calibri" pitchFamily="34" charset="-122"/>
                 <a:cs typeface="Calibri" pitchFamily="34" charset="-120"/>
               </a:rPr>
-              <a:t>3% de los 504 abiertos ya venció su fecha requerida. Foco en Eléctrica (3), Piping (5), Obras Civiles (0).</a:t>
+              <a:t>2,5% de los 553 abiertos ya venció su fecha requerida. Foco en Eléctrica (6), Piping (2), Obras Civiles (0).</a:t>
             </a:r>
             <a:endParaRPr lang="en-US" sz="1100" dirty="0"/>
           </a:p>
@@ -19697,7 +19631,7 @@
                 <a:ea typeface="Calibri" pitchFamily="34" charset="-122"/>
                 <a:cs typeface="Calibri" pitchFamily="34" charset="-120"/>
               </a:rPr>
-              <a:t>Ejecutar las 34 caminatas de Operables pendientes</a:t>
+              <a:t>Ejecutar las 31 caminatas de Operables pendientes</a:t>
             </a:r>
             <a:endParaRPr lang="en-US" sz="1400" dirty="0"/>
           </a:p>
@@ -19739,7 +19673,7 @@
                 <a:ea typeface="Calibri" pitchFamily="34" charset="-122"/>
                 <a:cs typeface="Calibri" pitchFamily="34" charset="-120"/>
               </a:rPr>
-              <a:t>La Caminata 2 va en 57,5% (46/80). Sin caminata no se levanta el punch final ni se habilita la entrega de la carpeta.</a:t>
+              <a:t>La Caminata 2 va en 61,3% (49/80). Sin caminata no se levanta el punch final ni se habilita la entrega de la carpeta.</a:t>
             </a:r>
             <a:endParaRPr lang="en-US" sz="1100" dirty="0"/>
           </a:p>
@@ -19839,7 +19773,7 @@
                 <a:ea typeface="Calibri" pitchFamily="34" charset="-122"/>
                 <a:cs typeface="Calibri" pitchFamily="34" charset="-120"/>
               </a:rPr>
-              <a:t>Sacar del armado interno las 53 carpetas retenidas</a:t>
+              <a:t>Sacar del armado interno las 52 carpetas retenidas</a:t>
             </a:r>
             <a:endParaRPr lang="en-US" sz="1400" dirty="0"/>
           </a:p>
@@ -19881,7 +19815,7 @@
                 <a:ea typeface="Calibri" pitchFamily="34" charset="-122"/>
                 <a:cs typeface="Calibri" pitchFamily="34" charset="-120"/>
               </a:rPr>
-              <a:t>15 están en preparación y 38 sin iniciar. Solo 42 de 95 (44,2%) llegaron al cliente; 4 volvieron rechazadas y hay que rearmarlas.</a:t>
+              <a:t>18 están en preparación y 34 sin iniciar. Solo 43 de 95 (45,3%) llegaron al cliente; 2 volvieron rechazadas y hay que rearmarlas.</a:t>
             </a:r>
             <a:endParaRPr lang="en-US" sz="1100" dirty="0"/>
           </a:p>
@@ -20023,7 +19957,7 @@
                 <a:ea typeface="Calibri" pitchFamily="34" charset="-122"/>
                 <a:cs typeface="Calibri" pitchFamily="34" charset="-120"/>
               </a:rPr>
-              <a:t>Concentra 224 P1 abiertos y 8 atrasados sobre 74 subsistemas. Es la ruta crítica del proyecto.</a:t>
+              <a:t>Concentra 256 P1 abiertos y 8 atrasados sobre 74 subsistemas. Es la ruta crítica del proyecto.</a:t>
             </a:r>
             <a:endParaRPr lang="en-US" sz="1100" dirty="0"/>
           </a:p>
@@ -20062,7 +19996,7 @@
                 <a:ea typeface="Calibri" pitchFamily="34" charset="-122"/>
                 <a:cs typeface="Calibri" pitchFamily="34" charset="-120"/>
               </a:rPr>
-              <a:t>Fuente: REPORTE_GERENCIAL + Listado de Puntos Punch Consolidado · Corte 18-08-2026 · Atrasos al 24-08-2026</a:t>
+              <a:t>Fuente: REPORTE_GERENCIAL + Listado de Puntos Punch Consolidado · Corte 25-08-2026 · Atrasos al 31-08-2026</a:t>
             </a:r>
             <a:endParaRPr lang="en-US" sz="850" dirty="0"/>
           </a:p>
@@ -20415,7 +20349,7 @@
                 <a:ea typeface="Calibri" pitchFamily="34" charset="-122"/>
                 <a:cs typeface="Calibri" pitchFamily="34" charset="-120"/>
               </a:rPr>
-              <a:t>Contrato 4600029355 · 218 subsistemas en 9 áreas · 2.062 detalles de terminación levantados.</a:t>
+              <a:t>Contrato 4600029355 · 218 subsistemas en 9 áreas · 2.078 detalles de terminación levantados.</a:t>
             </a:r>
             <a:endParaRPr lang="en-US" sz="1350" dirty="0"/>
           </a:p>
@@ -20454,7 +20388,7 @@
                 <a:ea typeface="Cambria" pitchFamily="34" charset="-122"/>
                 <a:cs typeface="Cambria" pitchFamily="34" charset="-120"/>
               </a:rPr>
-              <a:t>99,5%</a:t>
+              <a:t>99,1%</a:t>
             </a:r>
             <a:endParaRPr lang="en-US" sz="3400" dirty="0"/>
           </a:p>
@@ -20532,7 +20466,7 @@
                 <a:ea typeface="Cambria" pitchFamily="34" charset="-122"/>
                 <a:cs typeface="Cambria" pitchFamily="34" charset="-120"/>
               </a:rPr>
-              <a:t>98%</a:t>
+              <a:t>94,3%</a:t>
             </a:r>
             <a:endParaRPr lang="en-US" sz="3400" dirty="0"/>
           </a:p>
@@ -20610,7 +20544,7 @@
                 <a:ea typeface="Cambria" pitchFamily="34" charset="-122"/>
                 <a:cs typeface="Cambria" pitchFamily="34" charset="-120"/>
               </a:rPr>
-              <a:t>93,8%</a:t>
+              <a:t>94%</a:t>
             </a:r>
             <a:endParaRPr lang="en-US" sz="3400" dirty="0"/>
           </a:p>
@@ -20688,7 +20622,7 @@
                 <a:ea typeface="Cambria" pitchFamily="34" charset="-122"/>
                 <a:cs typeface="Cambria" pitchFamily="34" charset="-120"/>
               </a:rPr>
-              <a:t>90,6%</a:t>
+              <a:t>92,2%</a:t>
             </a:r>
             <a:endParaRPr lang="en-US" sz="3400" dirty="0"/>
           </a:p>
@@ -20766,7 +20700,7 @@
                 <a:ea typeface="Calibri" pitchFamily="34" charset="-122"/>
                 <a:cs typeface="Calibri" pitchFamily="34" charset="-120"/>
               </a:rPr>
-              <a:t>Atrasos calculados al 24-08-2026</a:t>
+              <a:t>Atrasos calculados al 31-08-2026</a:t>
             </a:r>
             <a:endParaRPr lang="en-US" sz="1100" dirty="0"/>
           </a:p>
@@ -20805,7 +20739,7 @@
                 <a:ea typeface="Calibri" pitchFamily="34" charset="-122"/>
                 <a:cs typeface="Calibri" pitchFamily="34" charset="-120"/>
               </a:rPr>
-              <a:t>Fuente: STATUS_SUBSISTEMAS_TALABRE + Detalle_de_Terminaciones · 218 subsistemas · 2.062 DT · Atrasos al 24-08-2026</a:t>
+              <a:t>Fuente: STATUS_SUBSISTEMAS_TALABRE + Detalle_de_Terminaciones · 218 subsistemas · 2.078 DT · Atrasos al 31-08-2026</a:t>
             </a:r>
             <a:endParaRPr lang="en-US" sz="850" dirty="0"/>
           </a:p>
@@ -21071,7 +21005,7 @@
                 <a:ea typeface="Cambria" pitchFamily="34" charset="-122"/>
                 <a:cs typeface="Cambria" pitchFamily="34" charset="-120"/>
               </a:rPr>
-              <a:t>99,5%</a:t>
+              <a:t>99,1%</a:t>
             </a:r>
             <a:endParaRPr lang="en-US" sz="3800" dirty="0"/>
           </a:p>
@@ -21110,7 +21044,7 @@
                 <a:ea typeface="Calibri" pitchFamily="34" charset="-122"/>
                 <a:cs typeface="Calibri" pitchFamily="34" charset="-120"/>
               </a:rPr>
-              <a:t>211/212 exigibles</a:t>
+              <a:t>215/217 exigibles</a:t>
             </a:r>
             <a:endParaRPr lang="en-US" sz="1300" dirty="0"/>
           </a:p>
@@ -21191,7 +21125,7 @@
                 <a:ea typeface="Calibri" pitchFamily="34" charset="-122"/>
                 <a:cs typeface="Calibri" pitchFamily="34" charset="-120"/>
               </a:rPr>
-              <a:t>96,8% del universo · 6 programadas en plazo · 1 con agenda vencida · 0 sin programar</a:t>
+              <a:t>98,6% del universo · 1 programadas en plazo · 2 con agenda vencida · 0 sin programar</a:t>
             </a:r>
             <a:endParaRPr lang="en-US" sz="950" dirty="0"/>
           </a:p>
@@ -21284,7 +21218,7 @@
                 <a:ea typeface="Cambria" pitchFamily="34" charset="-122"/>
                 <a:cs typeface="Cambria" pitchFamily="34" charset="-120"/>
               </a:rPr>
-              <a:t>98%</a:t>
+              <a:t>94,3%</a:t>
             </a:r>
             <a:endParaRPr lang="en-US" sz="3800" dirty="0"/>
           </a:p>
@@ -21323,7 +21257,7 @@
                 <a:ea typeface="Calibri" pitchFamily="34" charset="-122"/>
                 <a:cs typeface="Calibri" pitchFamily="34" charset="-120"/>
               </a:rPr>
-              <a:t>194/198 exigibles</a:t>
+              <a:t>198/210 exigibles</a:t>
             </a:r>
             <a:endParaRPr lang="en-US" sz="1300" dirty="0"/>
           </a:p>
@@ -21404,7 +21338,7 @@
                 <a:ea typeface="Calibri" pitchFamily="34" charset="-122"/>
                 <a:cs typeface="Calibri" pitchFamily="34" charset="-120"/>
               </a:rPr>
-              <a:t>89% del universo · 20 programadas en plazo · 4 con agenda vencida · 0 sin programar</a:t>
+              <a:t>90,8% del universo · 8 programadas en plazo · 12 con agenda vencida · 0 sin programar</a:t>
             </a:r>
             <a:endParaRPr lang="en-US" sz="950" dirty="0"/>
           </a:p>
@@ -21497,7 +21431,7 @@
                 <a:ea typeface="Cambria" pitchFamily="34" charset="-122"/>
                 <a:cs typeface="Cambria" pitchFamily="34" charset="-120"/>
               </a:rPr>
-              <a:t>93,8%</a:t>
+              <a:t>94%</a:t>
             </a:r>
             <a:endParaRPr lang="en-US" sz="3800" dirty="0"/>
           </a:p>
@@ -21536,7 +21470,7 @@
                 <a:ea typeface="Calibri" pitchFamily="34" charset="-122"/>
                 <a:cs typeface="Calibri" pitchFamily="34" charset="-120"/>
               </a:rPr>
-              <a:t>182/218 sobre 95%</a:t>
+              <a:t>185/218 sobre 95%</a:t>
             </a:r>
             <a:endParaRPr lang="en-US" sz="1300" dirty="0"/>
           </a:p>
@@ -21617,7 +21551,7 @@
                 <a:ea typeface="Calibri" pitchFamily="34" charset="-122"/>
                 <a:cs typeface="Calibri" pitchFamily="34" charset="-120"/>
               </a:rPr>
-              <a:t>6 subsistemas bajo 80% de avance</a:t>
+              <a:t>4 subsistemas bajo 80% de avance</a:t>
             </a:r>
             <a:endParaRPr lang="en-US" sz="950" dirty="0"/>
           </a:p>
@@ -21710,7 +21644,7 @@
                 <a:ea typeface="Cambria" pitchFamily="34" charset="-122"/>
                 <a:cs typeface="Cambria" pitchFamily="34" charset="-120"/>
               </a:rPr>
-              <a:t>91%</a:t>
+              <a:t>93,2%</a:t>
             </a:r>
             <a:endParaRPr lang="en-US" sz="3800" dirty="0"/>
           </a:p>
@@ -21749,7 +21683,7 @@
                 <a:ea typeface="Calibri" pitchFamily="34" charset="-122"/>
                 <a:cs typeface="Calibri" pitchFamily="34" charset="-120"/>
               </a:rPr>
-              <a:t>342/376</a:t>
+              <a:t>354/380</a:t>
             </a:r>
             <a:endParaRPr lang="en-US" sz="1300" dirty="0"/>
           </a:p>
@@ -21830,7 +21764,7 @@
                 <a:ea typeface="Calibri" pitchFamily="34" charset="-122"/>
                 <a:cs typeface="Calibri" pitchFamily="34" charset="-120"/>
               </a:rPr>
-              <a:t>34 abiertos · 14 atrasados</a:t>
+              <a:t>26 abiertos · 22 atrasados</a:t>
             </a:r>
             <a:endParaRPr lang="en-US" sz="950" dirty="0"/>
           </a:p>
@@ -21970,7 +21904,7 @@
                 <a:ea typeface="Calibri" pitchFamily="34" charset="-122"/>
                 <a:cs typeface="Calibri" pitchFamily="34" charset="-120"/>
               </a:rPr>
-              <a:t>91% de cierre en P1 (34 abiertos), pero 346 DT abiertos entre P2, P3 y P4 sobre un total de 380.</a:t>
+              <a:t>93,2% de cierre en P1 (26 abiertos), pero 326 DT abiertos entre P2, P3 y P4 sobre un total de 352.</a:t>
             </a:r>
             <a:endParaRPr lang="en-US" sz="1150" dirty="0"/>
           </a:p>
@@ -22049,7 +21983,7 @@
                 <a:ea typeface="Calibri" pitchFamily="34" charset="-122"/>
                 <a:cs typeface="Calibri" pitchFamily="34" charset="-120"/>
               </a:rPr>
-              <a:t>148 DT con la fecha de compromiso vencida; mediana de 23 días y el más antiguo lleva 158. Los 211 abiertos sin fecha de compromiso no se cuentan como atrasados.</a:t>
+              <a:t>125 DT con la fecha de compromiso vencida; mediana de 28 días y el más antiguo lleva 165. Los 211 abiertos sin fecha de compromiso no se cuentan como atrasados.</a:t>
             </a:r>
             <a:endParaRPr lang="en-US" sz="1150" dirty="0"/>
           </a:p>
@@ -22111,7 +22045,7 @@
                 <a:ea typeface="Calibri" pitchFamily="34" charset="-122"/>
                 <a:cs typeface="Calibri" pitchFamily="34" charset="-120"/>
               </a:rPr>
-              <a:t>Caminatas: 99,5% y 98% de lo exigible (C1 y C2).  </a:t>
+              <a:t>Caminatas: 99,1% y 94,3% de lo exigible (C1 y C2).  </a:t>
             </a:r>
             <a:pPr indent="0" marL="0">
               <a:lnSpc>
@@ -22128,7 +22062,7 @@
                 <a:ea typeface="Calibri" pitchFamily="34" charset="-122"/>
                 <a:cs typeface="Calibri" pitchFamily="34" charset="-120"/>
               </a:rPr>
-              <a:t>Caminata 1: 211/212 exigibles, 1 con agenda vencida. Caminata 2: 194/198, con 20 agendadas en plazo y 0 sin programar.</a:t>
+              <a:t>Caminata 1: 215/217 exigibles, 2 con agenda vencida. Caminata 2: 198/210, con 8 agendadas en plazo y 0 sin programar.</a:t>
             </a:r>
             <a:endParaRPr lang="en-US" sz="1150" dirty="0"/>
           </a:p>
@@ -22207,7 +22141,7 @@
                 <a:ea typeface="Calibri" pitchFamily="34" charset="-122"/>
                 <a:cs typeface="Calibri" pitchFamily="34" charset="-120"/>
               </a:rPr>
-              <a:t>Avance promedio 93,8%: 182 subsistemas sobre 95% y solo 6 bajo 80%.</a:t>
+              <a:t>Avance promedio 94%: 185 subsistemas sobre 95% y solo 4 bajo 80%.</a:t>
             </a:r>
             <a:endParaRPr lang="en-US" sz="1150" dirty="0"/>
           </a:p>
@@ -22246,7 +22180,7 @@
                 <a:ea typeface="Calibri" pitchFamily="34" charset="-122"/>
                 <a:cs typeface="Calibri" pitchFamily="34" charset="-120"/>
               </a:rPr>
-              <a:t>Fuente: STATUS_SUBSISTEMAS_TALABRE + Detalle_de_Terminaciones · 218 subsistemas · 2.062 DT · Atrasos al 24-08-2026</a:t>
+              <a:t>Fuente: STATUS_SUBSISTEMAS_TALABRE + Detalle_de_Terminaciones · 218 subsistemas · 2.078 DT · Atrasos al 31-08-2026</a:t>
             </a:r>
             <a:endParaRPr lang="en-US" sz="850" dirty="0"/>
           </a:p>
@@ -22497,7 +22431,7 @@
                 <a:ea typeface="Calibri" pitchFamily="34" charset="-122"/>
                 <a:cs typeface="Calibri" pitchFamily="34" charset="-120"/>
               </a:rPr>
-              <a:t>Caminata 2: 98% de lo exigible (194/198) — se descuentan 20 agendadas a fecha futura, que no son incumplimiento al corte. Talabre mide la carpeta como % de avance (PEC), no como estado de aprobación.</a:t>
+              <a:t>Caminata 2: 94,3% de lo exigible (198/210) — se descuentan 8 agendadas a fecha futura, que no son incumplimiento al corte. Talabre mide la carpeta como % de avance (PEC), no como estado de aprobación.</a:t>
             </a:r>
             <a:endParaRPr lang="en-US" sz="1350" dirty="0"/>
           </a:p>
@@ -22568,7 +22502,7 @@
                 <a:ea typeface="Calibri" pitchFamily="34" charset="-122"/>
                 <a:cs typeface="Calibri" pitchFamily="34" charset="-120"/>
               </a:rPr>
-              <a:t>Fuente: STATUS_SUBSISTEMAS_TALABRE + Detalle_de_Terminaciones · 218 subsistemas · 2.062 DT · Atrasos al 24-08-2026</a:t>
+              <a:t>Fuente: STATUS_SUBSISTEMAS_TALABRE + Detalle_de_Terminaciones · 218 subsistemas · 2.078 DT · Atrasos al 31-08-2026</a:t>
             </a:r>
             <a:endParaRPr lang="en-US" sz="850" dirty="0"/>
           </a:p>
@@ -22819,7 +22753,7 @@
                 <a:ea typeface="Calibri" pitchFamily="34" charset="-122"/>
                 <a:cs typeface="Calibri" pitchFamily="34" charset="-120"/>
               </a:rPr>
-              <a:t>2.062 DT levantados; 81,6% cerrados. Atrasado = DT abierto cuya fecha de compromiso de cierre ya venció al 24-08-2026.</a:t>
+              <a:t>2.078 DT levantados; 83,1% cerrados. Atrasado = DT abierto cuya fecha de compromiso de cierre ya venció al 31-08-2026.</a:t>
             </a:r>
             <a:endParaRPr lang="en-US" sz="1350" dirty="0"/>
           </a:p>
@@ -22974,7 +22908,7 @@
                 <a:ea typeface="Calibri" pitchFamily="34" charset="-122"/>
                 <a:cs typeface="Calibri" pitchFamily="34" charset="-120"/>
               </a:rPr>
-              <a:t>342/376</a:t>
+              <a:t>354/380</a:t>
             </a:r>
             <a:endParaRPr lang="en-US" sz="1050" dirty="0"/>
           </a:p>
@@ -23013,7 +22947,7 @@
                 <a:ea typeface="Calibri" pitchFamily="34" charset="-122"/>
                 <a:cs typeface="Calibri" pitchFamily="34" charset="-120"/>
               </a:rPr>
-              <a:t>91%</a:t>
+              <a:t>93,2%</a:t>
             </a:r>
             <a:endParaRPr lang="en-US" sz="1100" dirty="0"/>
           </a:p>
@@ -23048,7 +22982,7 @@
         <p:spPr>
           <a:xfrm>
             <a:off x="7936992" y="2688336"/>
-            <a:ext cx="3245206" cy="118872"/>
+            <a:ext cx="3323661" cy="118872"/>
           </a:xfrm>
           <a:prstGeom prst="rect">
             <a:avLst/>
@@ -23131,7 +23065,7 @@
                 <a:ea typeface="Calibri" pitchFamily="34" charset="-122"/>
                 <a:cs typeface="Calibri" pitchFamily="34" charset="-120"/>
               </a:rPr>
-              <a:t>1.256/1.388</a:t>
+              <a:t>1.288/1.400</a:t>
             </a:r>
             <a:endParaRPr lang="en-US" sz="1050" dirty="0"/>
           </a:p>
@@ -23170,7 +23104,7 @@
                 <a:ea typeface="Calibri" pitchFamily="34" charset="-122"/>
                 <a:cs typeface="Calibri" pitchFamily="34" charset="-120"/>
               </a:rPr>
-              <a:t>90,5%</a:t>
+              <a:t>92%</a:t>
             </a:r>
             <a:endParaRPr lang="en-US" sz="1100" dirty="0"/>
           </a:p>
@@ -23205,7 +23139,7 @@
         <p:spPr>
           <a:xfrm>
             <a:off x="7936992" y="3200400"/>
-            <a:ext cx="3227375" cy="118872"/>
+            <a:ext cx="3280867" cy="118872"/>
           </a:xfrm>
           <a:prstGeom prst="rect">
             <a:avLst/>
@@ -23744,7 +23678,7 @@
                 <a:ea typeface="Calibri" pitchFamily="34" charset="-122"/>
                 <a:cs typeface="Calibri" pitchFamily="34" charset="-120"/>
               </a:rPr>
-              <a:t>Mediana de 23 días vencidos; el más antiguo lleva 158. 90 entre 1-30 días, 48 entre 31-90 días, 10 entre 91-180 días.</a:t>
+              <a:t>Mediana de 28 días vencidos; el más antiguo lleva 165. 69 entre 1-30 días, 46 entre 31-90 días, 10 entre 91-180 días.</a:t>
             </a:r>
             <a:endParaRPr lang="en-US" sz="1150" dirty="0"/>
           </a:p>
@@ -23783,7 +23717,7 @@
                 <a:ea typeface="Calibri" pitchFamily="34" charset="-122"/>
                 <a:cs typeface="Calibri" pitchFamily="34" charset="-120"/>
               </a:rPr>
-              <a:t>Fuente: STATUS_SUBSISTEMAS_TALABRE + Detalle_de_Terminaciones · 218 subsistemas · 2.062 DT · Atrasos al 24-08-2026</a:t>
+              <a:t>Fuente: STATUS_SUBSISTEMAS_TALABRE + Detalle_de_Terminaciones · 218 subsistemas · 2.078 DT · Atrasos al 31-08-2026</a:t>
             </a:r>
             <a:endParaRPr lang="en-US" sz="850" dirty="0"/>
           </a:p>

</xml_diff>